<commit_message>
Create labelled versions of both indicator maps
</commit_message>
<xml_diff>
--- a/plotting/Map Labels.pptx
+++ b/plotting/Map Labels.pptx
@@ -6,6 +6,7 @@
   </p:sldMasterIdLst>
   <p:sldIdLst>
     <p:sldId id="256" r:id="rId2"/>
+    <p:sldId id="257" r:id="rId3"/>
   </p:sldIdLst>
   <p:sldSz cx="7326313" cy="6840538"/>
   <p:notesSz cx="6858000" cy="9144000"/>
@@ -104,7 +105,153 @@
       </a:defRPr>
     </a:lvl9pPr>
   </p:defaultTextStyle>
+  <p:extLst>
+    <p:ext uri="{EFAFB233-063F-42B5-8137-9DF3F51BA10A}">
+      <p15:sldGuideLst xmlns:p15="http://schemas.microsoft.com/office/powerpoint/2012/main"/>
+    </p:ext>
+  </p:extLst>
 </p:presentation>
+</file>
+
+<file path=ppt/changesInfos/changesInfo1.xml><?xml version="1.0" encoding="utf-8"?>
+<pc:chgInfo xmlns:a="http://schemas.openxmlformats.org/drawingml/2006/main" xmlns:r="http://schemas.openxmlformats.org/officeDocument/2006/relationships" xmlns:ac="http://schemas.microsoft.com/office/drawing/2013/main/command" xmlns:pc="http://schemas.microsoft.com/office/powerpoint/2013/main/command">
+  <pc:docChgLst>
+    <pc:chgData name="Sam Townley" userId="68c42a0746408205" providerId="LiveId" clId="{FE58AA54-8397-47B9-AD77-0B53CD4C599D}"/>
+    <pc:docChg chg="custSel modSld">
+      <pc:chgData name="Sam Townley" userId="68c42a0746408205" providerId="LiveId" clId="{FE58AA54-8397-47B9-AD77-0B53CD4C599D}" dt="2026-03-10T19:57:11.836" v="35" actId="732"/>
+      <pc:docMkLst>
+        <pc:docMk/>
+      </pc:docMkLst>
+      <pc:sldChg chg="addSp delSp modSp mod">
+        <pc:chgData name="Sam Townley" userId="68c42a0746408205" providerId="LiveId" clId="{FE58AA54-8397-47B9-AD77-0B53CD4C599D}" dt="2026-03-10T19:57:11.836" v="35" actId="732"/>
+        <pc:sldMkLst>
+          <pc:docMk/>
+          <pc:sldMk cId="1040528626" sldId="256"/>
+        </pc:sldMkLst>
+        <pc:spChg chg="del">
+          <ac:chgData name="Sam Townley" userId="68c42a0746408205" providerId="LiveId" clId="{FE58AA54-8397-47B9-AD77-0B53CD4C599D}" dt="2026-03-10T19:56:48.862" v="18" actId="478"/>
+          <ac:spMkLst>
+            <pc:docMk/>
+            <pc:sldMk cId="1040528626" sldId="256"/>
+            <ac:spMk id="2" creationId="{1B160CD0-C17C-F8B3-5DE7-FBC1C093D2C4}"/>
+          </ac:spMkLst>
+        </pc:spChg>
+        <pc:spChg chg="del">
+          <ac:chgData name="Sam Townley" userId="68c42a0746408205" providerId="LiveId" clId="{FE58AA54-8397-47B9-AD77-0B53CD4C599D}" dt="2026-03-10T19:56:48.202" v="17" actId="478"/>
+          <ac:spMkLst>
+            <pc:docMk/>
+            <pc:sldMk cId="1040528626" sldId="256"/>
+            <ac:spMk id="3" creationId="{38ABDD0D-9112-0369-389C-5A93CC6DC349}"/>
+          </ac:spMkLst>
+        </pc:spChg>
+        <pc:picChg chg="del">
+          <ac:chgData name="Sam Townley" userId="68c42a0746408205" providerId="LiveId" clId="{FE58AA54-8397-47B9-AD77-0B53CD4C599D}" dt="2026-03-10T19:56:17.119" v="0" actId="478"/>
+          <ac:picMkLst>
+            <pc:docMk/>
+            <pc:sldMk cId="1040528626" sldId="256"/>
+            <ac:picMk id="5" creationId="{11FB3594-2F56-CBDA-8628-AC712A0EC36D}"/>
+          </ac:picMkLst>
+        </pc:picChg>
+        <pc:picChg chg="add del mod ord">
+          <ac:chgData name="Sam Townley" userId="68c42a0746408205" providerId="LiveId" clId="{FE58AA54-8397-47B9-AD77-0B53CD4C599D}" dt="2026-03-10T19:56:46.062" v="16" actId="478"/>
+          <ac:picMkLst>
+            <pc:docMk/>
+            <pc:sldMk cId="1040528626" sldId="256"/>
+            <ac:picMk id="6" creationId="{A665D3D0-8562-1763-50C1-1F76420C7C95}"/>
+          </ac:picMkLst>
+        </pc:picChg>
+        <pc:picChg chg="add mod ord modCrop">
+          <ac:chgData name="Sam Townley" userId="68c42a0746408205" providerId="LiveId" clId="{FE58AA54-8397-47B9-AD77-0B53CD4C599D}" dt="2026-03-10T19:57:11.836" v="35" actId="732"/>
+          <ac:picMkLst>
+            <pc:docMk/>
+            <pc:sldMk cId="1040528626" sldId="256"/>
+            <ac:picMk id="8" creationId="{D0CAC861-D1E8-7747-347C-D4B38C6F2849}"/>
+          </ac:picMkLst>
+        </pc:picChg>
+      </pc:sldChg>
+    </pc:docChg>
+  </pc:docChgLst>
+  <pc:docChgLst>
+    <pc:chgData name="Sam Townley" userId="68c42a0746408205" providerId="LiveId" clId="{FE0E0C0B-E7CA-4A87-990B-63699E60333D}"/>
+    <pc:docChg chg="undo custSel addSld modSld">
+      <pc:chgData name="Sam Townley" userId="68c42a0746408205" providerId="LiveId" clId="{FE0E0C0B-E7CA-4A87-990B-63699E60333D}" dt="2026-03-11T11:29:45.890" v="27" actId="14100"/>
+      <pc:docMkLst>
+        <pc:docMk/>
+      </pc:docMkLst>
+      <pc:sldChg chg="addSp delSp modSp add mod">
+        <pc:chgData name="Sam Townley" userId="68c42a0746408205" providerId="LiveId" clId="{FE0E0C0B-E7CA-4A87-990B-63699E60333D}" dt="2026-03-11T11:29:45.890" v="27" actId="14100"/>
+        <pc:sldMkLst>
+          <pc:docMk/>
+          <pc:sldMk cId="4270986651" sldId="257"/>
+        </pc:sldMkLst>
+        <pc:spChg chg="mod">
+          <ac:chgData name="Sam Townley" userId="68c42a0746408205" providerId="LiveId" clId="{FE0E0C0B-E7CA-4A87-990B-63699E60333D}" dt="2026-03-11T11:29:27.713" v="22" actId="1076"/>
+          <ac:spMkLst>
+            <pc:docMk/>
+            <pc:sldMk cId="4270986651" sldId="257"/>
+            <ac:spMk id="20" creationId="{B5D9D2FF-672F-A0B7-F52F-D72C798C73C1}"/>
+          </ac:spMkLst>
+        </pc:spChg>
+        <pc:picChg chg="add mod ord modCrop">
+          <ac:chgData name="Sam Townley" userId="68c42a0746408205" providerId="LiveId" clId="{FE0E0C0B-E7CA-4A87-990B-63699E60333D}" dt="2026-03-11T11:29:31.218" v="24" actId="1076"/>
+          <ac:picMkLst>
+            <pc:docMk/>
+            <pc:sldMk cId="4270986651" sldId="257"/>
+            <ac:picMk id="3" creationId="{CA6A5A09-6332-3FCE-643F-411323A41AC7}"/>
+          </ac:picMkLst>
+        </pc:picChg>
+        <pc:picChg chg="del">
+          <ac:chgData name="Sam Townley" userId="68c42a0746408205" providerId="LiveId" clId="{FE0E0C0B-E7CA-4A87-990B-63699E60333D}" dt="2026-03-11T11:28:17.700" v="1" actId="478"/>
+          <ac:picMkLst>
+            <pc:docMk/>
+            <pc:sldMk cId="4270986651" sldId="257"/>
+            <ac:picMk id="8" creationId="{7C7D3585-6D9F-ABF8-7E46-35A005F68525}"/>
+          </ac:picMkLst>
+        </pc:picChg>
+        <pc:cxnChg chg="mod">
+          <ac:chgData name="Sam Townley" userId="68c42a0746408205" providerId="LiveId" clId="{FE0E0C0B-E7CA-4A87-990B-63699E60333D}" dt="2026-03-11T11:29:39.843" v="26" actId="14100"/>
+          <ac:cxnSpMkLst>
+            <pc:docMk/>
+            <pc:sldMk cId="4270986651" sldId="257"/>
+            <ac:cxnSpMk id="16" creationId="{C1E3BD8C-ED1F-A513-CB15-9C1C06F4B912}"/>
+          </ac:cxnSpMkLst>
+        </pc:cxnChg>
+        <pc:cxnChg chg="mod">
+          <ac:chgData name="Sam Townley" userId="68c42a0746408205" providerId="LiveId" clId="{FE0E0C0B-E7CA-4A87-990B-63699E60333D}" dt="2026-03-11T11:29:36.468" v="25" actId="14100"/>
+          <ac:cxnSpMkLst>
+            <pc:docMk/>
+            <pc:sldMk cId="4270986651" sldId="257"/>
+            <ac:cxnSpMk id="21" creationId="{7621BF10-3D73-CEF5-C479-DE8733684D27}"/>
+          </ac:cxnSpMkLst>
+        </pc:cxnChg>
+        <pc:cxnChg chg="mod">
+          <ac:chgData name="Sam Townley" userId="68c42a0746408205" providerId="LiveId" clId="{FE0E0C0B-E7CA-4A87-990B-63699E60333D}" dt="2026-03-11T11:29:09.096" v="18" actId="14100"/>
+          <ac:cxnSpMkLst>
+            <pc:docMk/>
+            <pc:sldMk cId="4270986651" sldId="257"/>
+            <ac:cxnSpMk id="32" creationId="{8667F4B3-59CE-149A-36FD-9108D7CF6DD6}"/>
+          </ac:cxnSpMkLst>
+        </pc:cxnChg>
+        <pc:cxnChg chg="mod">
+          <ac:chgData name="Sam Townley" userId="68c42a0746408205" providerId="LiveId" clId="{FE0E0C0B-E7CA-4A87-990B-63699E60333D}" dt="2026-03-11T11:29:45.890" v="27" actId="14100"/>
+          <ac:cxnSpMkLst>
+            <pc:docMk/>
+            <pc:sldMk cId="4270986651" sldId="257"/>
+            <ac:cxnSpMk id="38" creationId="{59FD0329-AB45-7BF2-F8AC-D01BC4A0FBC0}"/>
+          </ac:cxnSpMkLst>
+        </pc:cxnChg>
+        <pc:cxnChg chg="mod">
+          <ac:chgData name="Sam Townley" userId="68c42a0746408205" providerId="LiveId" clId="{FE0E0C0B-E7CA-4A87-990B-63699E60333D}" dt="2026-03-11T11:29:14.190" v="19" actId="14100"/>
+          <ac:cxnSpMkLst>
+            <pc:docMk/>
+            <pc:sldMk cId="4270986651" sldId="257"/>
+            <ac:cxnSpMk id="42" creationId="{58EE6CC5-978E-D62D-106C-02D764FDB065}"/>
+          </ac:cxnSpMkLst>
+        </pc:cxnChg>
+      </pc:sldChg>
+    </pc:docChg>
+  </pc:docChgLst>
+</pc:chgInfo>
 </file>
 
 <file path=ppt/slideLayouts/slideLayout1.xml><?xml version="1.0" encoding="utf-8"?>
@@ -238,7 +385,7 @@
           <a:p>
             <a:fld id="{2BDFCD92-024C-4532-B3B8-C05FEF7568C8}" type="datetimeFigureOut">
               <a:rPr lang="en-GB" smtClean="0"/>
-              <a:t>06/03/2026</a:t>
+              <a:t>11/03/2026</a:t>
             </a:fld>
             <a:endParaRPr lang="en-GB"/>
           </a:p>
@@ -408,7 +555,7 @@
           <a:p>
             <a:fld id="{2BDFCD92-024C-4532-B3B8-C05FEF7568C8}" type="datetimeFigureOut">
               <a:rPr lang="en-GB" smtClean="0"/>
-              <a:t>06/03/2026</a:t>
+              <a:t>11/03/2026</a:t>
             </a:fld>
             <a:endParaRPr lang="en-GB"/>
           </a:p>
@@ -588,7 +735,7 @@
           <a:p>
             <a:fld id="{2BDFCD92-024C-4532-B3B8-C05FEF7568C8}" type="datetimeFigureOut">
               <a:rPr lang="en-GB" smtClean="0"/>
-              <a:t>06/03/2026</a:t>
+              <a:t>11/03/2026</a:t>
             </a:fld>
             <a:endParaRPr lang="en-GB"/>
           </a:p>
@@ -758,7 +905,7 @@
           <a:p>
             <a:fld id="{2BDFCD92-024C-4532-B3B8-C05FEF7568C8}" type="datetimeFigureOut">
               <a:rPr lang="en-GB" smtClean="0"/>
-              <a:t>06/03/2026</a:t>
+              <a:t>11/03/2026</a:t>
             </a:fld>
             <a:endParaRPr lang="en-GB"/>
           </a:p>
@@ -1004,7 +1151,7 @@
           <a:p>
             <a:fld id="{2BDFCD92-024C-4532-B3B8-C05FEF7568C8}" type="datetimeFigureOut">
               <a:rPr lang="en-GB" smtClean="0"/>
-              <a:t>06/03/2026</a:t>
+              <a:t>11/03/2026</a:t>
             </a:fld>
             <a:endParaRPr lang="en-GB"/>
           </a:p>
@@ -1236,7 +1383,7 @@
           <a:p>
             <a:fld id="{2BDFCD92-024C-4532-B3B8-C05FEF7568C8}" type="datetimeFigureOut">
               <a:rPr lang="en-GB" smtClean="0"/>
-              <a:t>06/03/2026</a:t>
+              <a:t>11/03/2026</a:t>
             </a:fld>
             <a:endParaRPr lang="en-GB"/>
           </a:p>
@@ -1603,7 +1750,7 @@
           <a:p>
             <a:fld id="{2BDFCD92-024C-4532-B3B8-C05FEF7568C8}" type="datetimeFigureOut">
               <a:rPr lang="en-GB" smtClean="0"/>
-              <a:t>06/03/2026</a:t>
+              <a:t>11/03/2026</a:t>
             </a:fld>
             <a:endParaRPr lang="en-GB"/>
           </a:p>
@@ -1721,7 +1868,7 @@
           <a:p>
             <a:fld id="{2BDFCD92-024C-4532-B3B8-C05FEF7568C8}" type="datetimeFigureOut">
               <a:rPr lang="en-GB" smtClean="0"/>
-              <a:t>06/03/2026</a:t>
+              <a:t>11/03/2026</a:t>
             </a:fld>
             <a:endParaRPr lang="en-GB"/>
           </a:p>
@@ -1816,7 +1963,7 @@
           <a:p>
             <a:fld id="{2BDFCD92-024C-4532-B3B8-C05FEF7568C8}" type="datetimeFigureOut">
               <a:rPr lang="en-GB" smtClean="0"/>
-              <a:t>06/03/2026</a:t>
+              <a:t>11/03/2026</a:t>
             </a:fld>
             <a:endParaRPr lang="en-GB"/>
           </a:p>
@@ -2093,7 +2240,7 @@
           <a:p>
             <a:fld id="{2BDFCD92-024C-4532-B3B8-C05FEF7568C8}" type="datetimeFigureOut">
               <a:rPr lang="en-GB" smtClean="0"/>
-              <a:t>06/03/2026</a:t>
+              <a:t>11/03/2026</a:t>
             </a:fld>
             <a:endParaRPr lang="en-GB"/>
           </a:p>
@@ -2350,7 +2497,7 @@
           <a:p>
             <a:fld id="{2BDFCD92-024C-4532-B3B8-C05FEF7568C8}" type="datetimeFigureOut">
               <a:rPr lang="en-GB" smtClean="0"/>
-              <a:t>06/03/2026</a:t>
+              <a:t>11/03/2026</a:t>
             </a:fld>
             <a:endParaRPr lang="en-GB"/>
           </a:p>
@@ -2563,7 +2710,7 @@
           <a:p>
             <a:fld id="{2BDFCD92-024C-4532-B3B8-C05FEF7568C8}" type="datetimeFigureOut">
               <a:rPr lang="en-GB" smtClean="0"/>
-              <a:t>06/03/2026</a:t>
+              <a:t>11/03/2026</a:t>
             </a:fld>
             <a:endParaRPr lang="en-GB"/>
           </a:p>
@@ -2968,62 +3115,12 @@
           <a:chExt cx="0" cy="0"/>
         </a:xfrm>
       </p:grpSpPr>
-      <p:sp>
-        <p:nvSpPr>
-          <p:cNvPr id="2" name="Title 1">
+      <p:pic>
+        <p:nvPicPr>
+          <p:cNvPr id="8" name="Picture 7">
             <a:extLst>
               <a:ext uri="{FF2B5EF4-FFF2-40B4-BE49-F238E27FC236}">
-                <a16:creationId xmlns:a16="http://schemas.microsoft.com/office/drawing/2014/main" id="{1B160CD0-C17C-F8B3-5DE7-FBC1C093D2C4}"/>
-              </a:ext>
-            </a:extLst>
-          </p:cNvPr>
-          <p:cNvSpPr>
-            <a:spLocks noGrp="1"/>
-          </p:cNvSpPr>
-          <p:nvPr>
-            <p:ph type="ctrTitle"/>
-          </p:nvPr>
-        </p:nvSpPr>
-        <p:spPr/>
-        <p:txBody>
-          <a:bodyPr/>
-          <a:lstStyle/>
-          <a:p>
-            <a:endParaRPr lang="en-GB"/>
-          </a:p>
-        </p:txBody>
-      </p:sp>
-      <p:sp>
-        <p:nvSpPr>
-          <p:cNvPr id="3" name="Subtitle 2">
-            <a:extLst>
-              <a:ext uri="{FF2B5EF4-FFF2-40B4-BE49-F238E27FC236}">
-                <a16:creationId xmlns:a16="http://schemas.microsoft.com/office/drawing/2014/main" id="{38ABDD0D-9112-0369-389C-5A93CC6DC349}"/>
-              </a:ext>
-            </a:extLst>
-          </p:cNvPr>
-          <p:cNvSpPr>
-            <a:spLocks noGrp="1"/>
-          </p:cNvSpPr>
-          <p:nvPr>
-            <p:ph type="subTitle" idx="1"/>
-          </p:nvPr>
-        </p:nvSpPr>
-        <p:spPr/>
-        <p:txBody>
-          <a:bodyPr/>
-          <a:lstStyle/>
-          <a:p>
-            <a:endParaRPr lang="en-GB"/>
-          </a:p>
-        </p:txBody>
-      </p:sp>
-      <p:pic>
-        <p:nvPicPr>
-          <p:cNvPr id="5" name="Picture 4">
-            <a:extLst>
-              <a:ext uri="{FF2B5EF4-FFF2-40B4-BE49-F238E27FC236}">
-                <a16:creationId xmlns:a16="http://schemas.microsoft.com/office/drawing/2014/main" id="{11FB3594-2F56-CBDA-8628-AC712A0EC36D}"/>
+                <a16:creationId xmlns:a16="http://schemas.microsoft.com/office/drawing/2014/main" id="{D0CAC861-D1E8-7747-347C-D4B38C6F2849}"/>
               </a:ext>
             </a:extLst>
           </p:cNvPr>
@@ -3040,7 +3137,7 @@
               </a:ext>
             </a:extLst>
           </a:blip>
-          <a:srcRect l="19593"/>
+          <a:srcRect l="19674"/>
           <a:stretch>
             <a:fillRect/>
           </a:stretch>
@@ -3048,7 +3145,7 @@
         <p:spPr>
           <a:xfrm>
             <a:off x="0" y="0"/>
-            <a:ext cx="7333629" cy="6840538"/>
+            <a:ext cx="7326313" cy="6840538"/>
           </a:xfrm>
           <a:prstGeom prst="rect">
             <a:avLst/>
@@ -3574,6 +3671,594 @@
     <p:extLst>
       <p:ext uri="{BB962C8B-B14F-4D97-AF65-F5344CB8AC3E}">
         <p14:creationId xmlns:p14="http://schemas.microsoft.com/office/powerpoint/2010/main" val="1040528626"/>
+      </p:ext>
+    </p:extLst>
+  </p:cSld>
+  <p:clrMapOvr>
+    <a:masterClrMapping/>
+  </p:clrMapOvr>
+</p:sld>
+</file>
+
+<file path=ppt/slides/slide2.xml><?xml version="1.0" encoding="utf-8"?>
+<p:sld xmlns:a="http://schemas.openxmlformats.org/drawingml/2006/main" xmlns:r="http://schemas.openxmlformats.org/officeDocument/2006/relationships" xmlns:p="http://schemas.openxmlformats.org/presentationml/2006/main">
+  <p:cSld>
+    <p:spTree>
+      <p:nvGrpSpPr>
+        <p:cNvPr id="1" name="">
+          <a:extLst>
+            <a:ext uri="{FF2B5EF4-FFF2-40B4-BE49-F238E27FC236}">
+              <a16:creationId xmlns:a16="http://schemas.microsoft.com/office/drawing/2014/main" id="{F9079697-7E96-4372-F3F8-FB73678029B8}"/>
+            </a:ext>
+          </a:extLst>
+        </p:cNvPr>
+        <p:cNvGrpSpPr/>
+        <p:nvPr/>
+      </p:nvGrpSpPr>
+      <p:grpSpPr>
+        <a:xfrm>
+          <a:off x="0" y="0"/>
+          <a:ext cx="0" cy="0"/>
+          <a:chOff x="0" y="0"/>
+          <a:chExt cx="0" cy="0"/>
+        </a:xfrm>
+      </p:grpSpPr>
+      <p:pic>
+        <p:nvPicPr>
+          <p:cNvPr id="3" name="Picture 2">
+            <a:extLst>
+              <a:ext uri="{FF2B5EF4-FFF2-40B4-BE49-F238E27FC236}">
+                <a16:creationId xmlns:a16="http://schemas.microsoft.com/office/drawing/2014/main" id="{CA6A5A09-6332-3FCE-643F-411323A41AC7}"/>
+              </a:ext>
+            </a:extLst>
+          </p:cNvPr>
+          <p:cNvPicPr>
+            <a:picLocks noChangeAspect="1"/>
+          </p:cNvPicPr>
+          <p:nvPr/>
+        </p:nvPicPr>
+        <p:blipFill>
+          <a:blip r:embed="rId2">
+            <a:extLst>
+              <a:ext uri="{28A0092B-C50C-407E-A947-70E740481C1C}">
+                <a14:useLocalDpi xmlns:a14="http://schemas.microsoft.com/office/drawing/2010/main" val="0"/>
+              </a:ext>
+            </a:extLst>
+          </a:blip>
+          <a:srcRect l="20174"/>
+          <a:stretch>
+            <a:fillRect/>
+          </a:stretch>
+        </p:blipFill>
+        <p:spPr>
+          <a:xfrm>
+            <a:off x="0" y="-42860"/>
+            <a:ext cx="7326314" cy="6883397"/>
+          </a:xfrm>
+          <a:prstGeom prst="rect">
+            <a:avLst/>
+          </a:prstGeom>
+        </p:spPr>
+      </p:pic>
+      <p:sp>
+        <p:nvSpPr>
+          <p:cNvPr id="11" name="Rectangle: Rounded Corners 10">
+            <a:extLst>
+              <a:ext uri="{FF2B5EF4-FFF2-40B4-BE49-F238E27FC236}">
+                <a16:creationId xmlns:a16="http://schemas.microsoft.com/office/drawing/2014/main" id="{D78A4E7B-26F3-8B16-3740-1D21B8F1A035}"/>
+              </a:ext>
+            </a:extLst>
+          </p:cNvPr>
+          <p:cNvSpPr/>
+          <p:nvPr/>
+        </p:nvSpPr>
+        <p:spPr>
+          <a:xfrm>
+            <a:off x="3696144" y="5741679"/>
+            <a:ext cx="1499025" cy="337529"/>
+          </a:xfrm>
+          <a:prstGeom prst="roundRect">
+            <a:avLst/>
+          </a:prstGeom>
+          <a:solidFill>
+            <a:schemeClr val="bg1"/>
+          </a:solidFill>
+          <a:ln>
+            <a:solidFill>
+              <a:schemeClr val="tx1"/>
+            </a:solidFill>
+          </a:ln>
+        </p:spPr>
+        <p:style>
+          <a:lnRef idx="2">
+            <a:schemeClr val="accent1">
+              <a:shade val="15000"/>
+            </a:schemeClr>
+          </a:lnRef>
+          <a:fillRef idx="1">
+            <a:schemeClr val="accent1"/>
+          </a:fillRef>
+          <a:effectRef idx="0">
+            <a:schemeClr val="accent1"/>
+          </a:effectRef>
+          <a:fontRef idx="minor">
+            <a:schemeClr val="lt1"/>
+          </a:fontRef>
+        </p:style>
+        <p:txBody>
+          <a:bodyPr rtlCol="0" anchor="ctr"/>
+          <a:lstStyle/>
+          <a:p>
+            <a:pPr algn="ctr"/>
+            <a:r>
+              <a:rPr lang="en-GB" sz="1955" dirty="0">
+                <a:solidFill>
+                  <a:sysClr val="windowText" lastClr="000000"/>
+                </a:solidFill>
+              </a:rPr>
+              <a:t>London</a:t>
+            </a:r>
+          </a:p>
+        </p:txBody>
+      </p:sp>
+      <p:cxnSp>
+        <p:nvCxnSpPr>
+          <p:cNvPr id="16" name="Straight Arrow Connector 15">
+            <a:extLst>
+              <a:ext uri="{FF2B5EF4-FFF2-40B4-BE49-F238E27FC236}">
+                <a16:creationId xmlns:a16="http://schemas.microsoft.com/office/drawing/2014/main" id="{C1E3BD8C-ED1F-A513-CB15-9C1C06F4B912}"/>
+              </a:ext>
+            </a:extLst>
+          </p:cNvPr>
+          <p:cNvCxnSpPr>
+            <a:cxnSpLocks/>
+            <a:stCxn id="11" idx="0"/>
+          </p:cNvCxnSpPr>
+          <p:nvPr/>
+        </p:nvCxnSpPr>
+        <p:spPr>
+          <a:xfrm flipH="1" flipV="1">
+            <a:off x="3988340" y="4961106"/>
+            <a:ext cx="457317" cy="780573"/>
+          </a:xfrm>
+          <a:prstGeom prst="straightConnector1">
+            <a:avLst/>
+          </a:prstGeom>
+          <a:ln>
+            <a:tailEnd type="triangle"/>
+          </a:ln>
+        </p:spPr>
+        <p:style>
+          <a:lnRef idx="3">
+            <a:schemeClr val="dk1"/>
+          </a:lnRef>
+          <a:fillRef idx="0">
+            <a:schemeClr val="dk1"/>
+          </a:fillRef>
+          <a:effectRef idx="2">
+            <a:schemeClr val="dk1"/>
+          </a:effectRef>
+          <a:fontRef idx="minor">
+            <a:schemeClr val="tx1"/>
+          </a:fontRef>
+        </p:style>
+      </p:cxnSp>
+      <p:sp>
+        <p:nvSpPr>
+          <p:cNvPr id="20" name="Rectangle: Rounded Corners 19">
+            <a:extLst>
+              <a:ext uri="{FF2B5EF4-FFF2-40B4-BE49-F238E27FC236}">
+                <a16:creationId xmlns:a16="http://schemas.microsoft.com/office/drawing/2014/main" id="{B5D9D2FF-672F-A0B7-F52F-D72C798C73C1}"/>
+              </a:ext>
+            </a:extLst>
+          </p:cNvPr>
+          <p:cNvSpPr/>
+          <p:nvPr/>
+        </p:nvSpPr>
+        <p:spPr>
+          <a:xfrm>
+            <a:off x="105258" y="4410420"/>
+            <a:ext cx="1499025" cy="337529"/>
+          </a:xfrm>
+          <a:prstGeom prst="roundRect">
+            <a:avLst/>
+          </a:prstGeom>
+          <a:solidFill>
+            <a:schemeClr val="bg1"/>
+          </a:solidFill>
+          <a:ln>
+            <a:solidFill>
+              <a:schemeClr val="tx1"/>
+            </a:solidFill>
+          </a:ln>
+        </p:spPr>
+        <p:style>
+          <a:lnRef idx="2">
+            <a:schemeClr val="accent1">
+              <a:shade val="15000"/>
+            </a:schemeClr>
+          </a:lnRef>
+          <a:fillRef idx="1">
+            <a:schemeClr val="accent1"/>
+          </a:fillRef>
+          <a:effectRef idx="0">
+            <a:schemeClr val="accent1"/>
+          </a:effectRef>
+          <a:fontRef idx="minor">
+            <a:schemeClr val="lt1"/>
+          </a:fontRef>
+        </p:style>
+        <p:txBody>
+          <a:bodyPr rtlCol="0" anchor="ctr"/>
+          <a:lstStyle/>
+          <a:p>
+            <a:pPr algn="ctr"/>
+            <a:r>
+              <a:rPr lang="en-GB" sz="1955" dirty="0">
+                <a:solidFill>
+                  <a:sysClr val="windowText" lastClr="000000"/>
+                </a:solidFill>
+              </a:rPr>
+              <a:t>Bristol</a:t>
+            </a:r>
+          </a:p>
+        </p:txBody>
+      </p:sp>
+      <p:cxnSp>
+        <p:nvCxnSpPr>
+          <p:cNvPr id="21" name="Straight Arrow Connector 20">
+            <a:extLst>
+              <a:ext uri="{FF2B5EF4-FFF2-40B4-BE49-F238E27FC236}">
+                <a16:creationId xmlns:a16="http://schemas.microsoft.com/office/drawing/2014/main" id="{7621BF10-3D73-CEF5-C479-DE8733684D27}"/>
+              </a:ext>
+            </a:extLst>
+          </p:cNvPr>
+          <p:cNvCxnSpPr>
+            <a:cxnSpLocks/>
+            <a:stCxn id="20" idx="3"/>
+          </p:cNvCxnSpPr>
+          <p:nvPr/>
+        </p:nvCxnSpPr>
+        <p:spPr>
+          <a:xfrm>
+            <a:off x="1604283" y="4579185"/>
+            <a:ext cx="691445" cy="90092"/>
+          </a:xfrm>
+          <a:prstGeom prst="straightConnector1">
+            <a:avLst/>
+          </a:prstGeom>
+          <a:ln>
+            <a:tailEnd type="triangle"/>
+          </a:ln>
+        </p:spPr>
+        <p:style>
+          <a:lnRef idx="3">
+            <a:schemeClr val="dk1"/>
+          </a:lnRef>
+          <a:fillRef idx="0">
+            <a:schemeClr val="dk1"/>
+          </a:fillRef>
+          <a:effectRef idx="2">
+            <a:schemeClr val="dk1"/>
+          </a:effectRef>
+          <a:fontRef idx="minor">
+            <a:schemeClr val="tx1"/>
+          </a:fontRef>
+        </p:style>
+      </p:cxnSp>
+      <p:sp>
+        <p:nvSpPr>
+          <p:cNvPr id="30" name="Rectangle: Rounded Corners 29">
+            <a:extLst>
+              <a:ext uri="{FF2B5EF4-FFF2-40B4-BE49-F238E27FC236}">
+                <a16:creationId xmlns:a16="http://schemas.microsoft.com/office/drawing/2014/main" id="{54CAB969-9F18-7141-E35F-4E0FEF9675D3}"/>
+              </a:ext>
+            </a:extLst>
+          </p:cNvPr>
+          <p:cNvSpPr/>
+          <p:nvPr/>
+        </p:nvSpPr>
+        <p:spPr>
+          <a:xfrm>
+            <a:off x="190257" y="3500299"/>
+            <a:ext cx="1585062" cy="337529"/>
+          </a:xfrm>
+          <a:prstGeom prst="roundRect">
+            <a:avLst/>
+          </a:prstGeom>
+          <a:solidFill>
+            <a:schemeClr val="bg1"/>
+          </a:solidFill>
+          <a:ln>
+            <a:solidFill>
+              <a:schemeClr val="tx1"/>
+            </a:solidFill>
+          </a:ln>
+        </p:spPr>
+        <p:style>
+          <a:lnRef idx="2">
+            <a:schemeClr val="accent1">
+              <a:shade val="15000"/>
+            </a:schemeClr>
+          </a:lnRef>
+          <a:fillRef idx="1">
+            <a:schemeClr val="accent1"/>
+          </a:fillRef>
+          <a:effectRef idx="0">
+            <a:schemeClr val="accent1"/>
+          </a:effectRef>
+          <a:fontRef idx="minor">
+            <a:schemeClr val="lt1"/>
+          </a:fontRef>
+        </p:style>
+        <p:txBody>
+          <a:bodyPr rtlCol="0" anchor="ctr"/>
+          <a:lstStyle/>
+          <a:p>
+            <a:pPr algn="ctr"/>
+            <a:r>
+              <a:rPr lang="en-GB" sz="1955" dirty="0">
+                <a:solidFill>
+                  <a:sysClr val="windowText" lastClr="000000"/>
+                </a:solidFill>
+              </a:rPr>
+              <a:t>Birmingham</a:t>
+            </a:r>
+          </a:p>
+        </p:txBody>
+      </p:sp>
+      <p:sp>
+        <p:nvSpPr>
+          <p:cNvPr id="31" name="Rectangle: Rounded Corners 30">
+            <a:extLst>
+              <a:ext uri="{FF2B5EF4-FFF2-40B4-BE49-F238E27FC236}">
+                <a16:creationId xmlns:a16="http://schemas.microsoft.com/office/drawing/2014/main" id="{3DACA100-BD4F-1909-771C-1C0469877D64}"/>
+              </a:ext>
+            </a:extLst>
+          </p:cNvPr>
+          <p:cNvSpPr/>
+          <p:nvPr/>
+        </p:nvSpPr>
+        <p:spPr>
+          <a:xfrm>
+            <a:off x="276294" y="2183780"/>
+            <a:ext cx="1499025" cy="337529"/>
+          </a:xfrm>
+          <a:prstGeom prst="roundRect">
+            <a:avLst/>
+          </a:prstGeom>
+          <a:solidFill>
+            <a:schemeClr val="bg1"/>
+          </a:solidFill>
+          <a:ln>
+            <a:solidFill>
+              <a:schemeClr val="tx1"/>
+            </a:solidFill>
+          </a:ln>
+        </p:spPr>
+        <p:style>
+          <a:lnRef idx="2">
+            <a:schemeClr val="accent1">
+              <a:shade val="15000"/>
+            </a:schemeClr>
+          </a:lnRef>
+          <a:fillRef idx="1">
+            <a:schemeClr val="accent1"/>
+          </a:fillRef>
+          <a:effectRef idx="0">
+            <a:schemeClr val="accent1"/>
+          </a:effectRef>
+          <a:fontRef idx="minor">
+            <a:schemeClr val="lt1"/>
+          </a:fontRef>
+        </p:style>
+        <p:txBody>
+          <a:bodyPr rtlCol="0" anchor="ctr"/>
+          <a:lstStyle/>
+          <a:p>
+            <a:pPr algn="ctr"/>
+            <a:r>
+              <a:rPr lang="en-GB" sz="1955" dirty="0">
+                <a:solidFill>
+                  <a:sysClr val="windowText" lastClr="000000"/>
+                </a:solidFill>
+              </a:rPr>
+              <a:t>Liverpool</a:t>
+            </a:r>
+          </a:p>
+        </p:txBody>
+      </p:sp>
+      <p:cxnSp>
+        <p:nvCxnSpPr>
+          <p:cNvPr id="32" name="Straight Arrow Connector 31">
+            <a:extLst>
+              <a:ext uri="{FF2B5EF4-FFF2-40B4-BE49-F238E27FC236}">
+                <a16:creationId xmlns:a16="http://schemas.microsoft.com/office/drawing/2014/main" id="{8667F4B3-59CE-149A-36FD-9108D7CF6DD6}"/>
+              </a:ext>
+            </a:extLst>
+          </p:cNvPr>
+          <p:cNvCxnSpPr>
+            <a:cxnSpLocks/>
+            <a:stCxn id="31" idx="2"/>
+          </p:cNvCxnSpPr>
+          <p:nvPr/>
+        </p:nvCxnSpPr>
+        <p:spPr>
+          <a:xfrm>
+            <a:off x="1025807" y="2521309"/>
+            <a:ext cx="1025806" cy="240202"/>
+          </a:xfrm>
+          <a:prstGeom prst="straightConnector1">
+            <a:avLst/>
+          </a:prstGeom>
+          <a:ln>
+            <a:tailEnd type="triangle"/>
+          </a:ln>
+        </p:spPr>
+        <p:style>
+          <a:lnRef idx="3">
+            <a:schemeClr val="dk1"/>
+          </a:lnRef>
+          <a:fillRef idx="0">
+            <a:schemeClr val="dk1"/>
+          </a:fillRef>
+          <a:effectRef idx="2">
+            <a:schemeClr val="dk1"/>
+          </a:effectRef>
+          <a:fontRef idx="minor">
+            <a:schemeClr val="tx1"/>
+          </a:fontRef>
+        </p:style>
+      </p:cxnSp>
+      <p:cxnSp>
+        <p:nvCxnSpPr>
+          <p:cNvPr id="38" name="Straight Arrow Connector 37">
+            <a:extLst>
+              <a:ext uri="{FF2B5EF4-FFF2-40B4-BE49-F238E27FC236}">
+                <a16:creationId xmlns:a16="http://schemas.microsoft.com/office/drawing/2014/main" id="{59FD0329-AB45-7BF2-F8AC-D01BC4A0FBC0}"/>
+              </a:ext>
+            </a:extLst>
+          </p:cNvPr>
+          <p:cNvCxnSpPr>
+            <a:cxnSpLocks/>
+            <a:stCxn id="30" idx="3"/>
+          </p:cNvCxnSpPr>
+          <p:nvPr/>
+        </p:nvCxnSpPr>
+        <p:spPr>
+          <a:xfrm>
+            <a:off x="1775319" y="3669064"/>
+            <a:ext cx="802511" cy="71437"/>
+          </a:xfrm>
+          <a:prstGeom prst="straightConnector1">
+            <a:avLst/>
+          </a:prstGeom>
+          <a:ln>
+            <a:tailEnd type="triangle"/>
+          </a:ln>
+        </p:spPr>
+        <p:style>
+          <a:lnRef idx="3">
+            <a:schemeClr val="dk1"/>
+          </a:lnRef>
+          <a:fillRef idx="0">
+            <a:schemeClr val="dk1"/>
+          </a:fillRef>
+          <a:effectRef idx="2">
+            <a:schemeClr val="dk1"/>
+          </a:effectRef>
+          <a:fontRef idx="minor">
+            <a:schemeClr val="tx1"/>
+          </a:fontRef>
+        </p:style>
+      </p:cxnSp>
+      <p:sp>
+        <p:nvSpPr>
+          <p:cNvPr id="41" name="Rectangle: Rounded Corners 40">
+            <a:extLst>
+              <a:ext uri="{FF2B5EF4-FFF2-40B4-BE49-F238E27FC236}">
+                <a16:creationId xmlns:a16="http://schemas.microsoft.com/office/drawing/2014/main" id="{24BE081C-0793-EB46-4309-97DE90088D65}"/>
+              </a:ext>
+            </a:extLst>
+          </p:cNvPr>
+          <p:cNvSpPr/>
+          <p:nvPr/>
+        </p:nvSpPr>
+        <p:spPr>
+          <a:xfrm>
+            <a:off x="3590306" y="1327459"/>
+            <a:ext cx="1499025" cy="337529"/>
+          </a:xfrm>
+          <a:prstGeom prst="roundRect">
+            <a:avLst/>
+          </a:prstGeom>
+          <a:solidFill>
+            <a:schemeClr val="bg1"/>
+          </a:solidFill>
+          <a:ln>
+            <a:solidFill>
+              <a:schemeClr val="tx1"/>
+            </a:solidFill>
+          </a:ln>
+        </p:spPr>
+        <p:style>
+          <a:lnRef idx="2">
+            <a:schemeClr val="accent1">
+              <a:shade val="15000"/>
+            </a:schemeClr>
+          </a:lnRef>
+          <a:fillRef idx="1">
+            <a:schemeClr val="accent1"/>
+          </a:fillRef>
+          <a:effectRef idx="0">
+            <a:schemeClr val="accent1"/>
+          </a:effectRef>
+          <a:fontRef idx="minor">
+            <a:schemeClr val="lt1"/>
+          </a:fontRef>
+        </p:style>
+        <p:txBody>
+          <a:bodyPr rtlCol="0" anchor="ctr"/>
+          <a:lstStyle/>
+          <a:p>
+            <a:pPr algn="ctr"/>
+            <a:r>
+              <a:rPr lang="en-GB" sz="1955" dirty="0">
+                <a:solidFill>
+                  <a:sysClr val="windowText" lastClr="000000"/>
+                </a:solidFill>
+              </a:rPr>
+              <a:t>Newcastle</a:t>
+            </a:r>
+          </a:p>
+        </p:txBody>
+      </p:sp>
+      <p:cxnSp>
+        <p:nvCxnSpPr>
+          <p:cNvPr id="42" name="Straight Arrow Connector 41">
+            <a:extLst>
+              <a:ext uri="{FF2B5EF4-FFF2-40B4-BE49-F238E27FC236}">
+                <a16:creationId xmlns:a16="http://schemas.microsoft.com/office/drawing/2014/main" id="{58EE6CC5-978E-D62D-106C-02D764FDB065}"/>
+              </a:ext>
+            </a:extLst>
+          </p:cNvPr>
+          <p:cNvCxnSpPr>
+            <a:cxnSpLocks/>
+            <a:stCxn id="41" idx="1"/>
+          </p:cNvCxnSpPr>
+          <p:nvPr/>
+        </p:nvCxnSpPr>
+        <p:spPr>
+          <a:xfrm flipH="1" flipV="1">
+            <a:off x="3200400" y="1410511"/>
+            <a:ext cx="389906" cy="85713"/>
+          </a:xfrm>
+          <a:prstGeom prst="straightConnector1">
+            <a:avLst/>
+          </a:prstGeom>
+          <a:ln>
+            <a:tailEnd type="triangle"/>
+          </a:ln>
+        </p:spPr>
+        <p:style>
+          <a:lnRef idx="3">
+            <a:schemeClr val="dk1"/>
+          </a:lnRef>
+          <a:fillRef idx="0">
+            <a:schemeClr val="dk1"/>
+          </a:fillRef>
+          <a:effectRef idx="2">
+            <a:schemeClr val="dk1"/>
+          </a:effectRef>
+          <a:fontRef idx="minor">
+            <a:schemeClr val="tx1"/>
+          </a:fontRef>
+        </p:style>
+      </p:cxnSp>
+    </p:spTree>
+    <p:extLst>
+      <p:ext uri="{BB962C8B-B14F-4D97-AF65-F5344CB8AC3E}">
+        <p14:creationId xmlns:p14="http://schemas.microsoft.com/office/powerpoint/2010/main" val="4270986651"/>
       </p:ext>
     </p:extLst>
   </p:cSld>

</xml_diff>